<commit_message>
Update PPTX and presentation.html with clickable links and full screen presentation URL
</commit_message>
<xml_diff>
--- a/Portfolio_Presentation_Bapanapalli_Shankar.pptx
+++ b/Portfolio_Presentation_Bapanapalli_Shankar.pptx
@@ -3144,8 +3144,8 @@
         </p:nvSpPr>
         <p:spPr>
           <a:xfrm>
-            <a:off x="731520" y="2011680"/>
-            <a:ext cx="137160" cy="2926080"/>
+            <a:off x="731520" y="1645920"/>
+            <a:ext cx="137160" cy="3291840"/>
           </a:xfrm>
           <a:prstGeom prst="rect">
             <a:avLst/>
@@ -3187,8 +3187,8 @@
         </p:nvSpPr>
         <p:spPr>
           <a:xfrm>
-            <a:off x="1097280" y="1828800"/>
-            <a:ext cx="10058400" cy="1828800"/>
+            <a:off x="1097280" y="1463040"/>
+            <a:ext cx="10058400" cy="2011680"/>
           </a:xfrm>
           <a:prstGeom prst="rect">
             <a:avLst/>
@@ -3202,7 +3202,7 @@
           <a:lstStyle/>
           <a:p>
             <a:pPr>
-              <a:defRPr sz="3600" b="1">
+              <a:defRPr sz="3400" b="1">
                 <a:solidFill>
                   <a:srgbClr val="F8FAFC"/>
                 </a:solidFill>
@@ -3211,6 +3211,22 @@
             </a:pPr>
             <a:r>
               <a:t>PORTFOLIO WEBSITE PRESENTATION</a:t>
+            </a:r>
+          </a:p>
+          <a:p>
+            <a:pPr>
+              <a:spcBef>
+                <a:spcPts val="800"/>
+              </a:spcBef>
+              <a:defRPr sz="1800">
+                <a:solidFill>
+                  <a:srgbClr val="059669"/>
+                </a:solidFill>
+                <a:latin typeface="Arial"/>
+              </a:defRPr>
+            </a:pPr>
+            <a:r>
+              <a:t>Bapanapalli Shankar — Full Stack &amp; AI Data Analyst</a:t>
             </a:r>
           </a:p>
           <a:p>
@@ -3218,23 +3234,7 @@
               <a:spcBef>
                 <a:spcPts val="1000"/>
               </a:spcBef>
-              <a:defRPr sz="2000">
-                <a:solidFill>
-                  <a:srgbClr val="059669"/>
-                </a:solidFill>
-                <a:latin typeface="Arial"/>
-              </a:defRPr>
-            </a:pPr>
-            <a:r>
-              <a:t>Bapanapalli Shankar — Full Stack &amp; AI Data Analyst</a:t>
-            </a:r>
-          </a:p>
-          <a:p>
-            <a:pPr>
-              <a:spcBef>
-                <a:spcPts val="1500"/>
-              </a:spcBef>
-              <a:defRPr sz="1500">
+              <a:defRPr sz="1400">
                 <a:solidFill>
                   <a:srgbClr val="94A3B8"/>
                 </a:solidFill>
@@ -3255,8 +3255,8 @@
         </p:nvSpPr>
         <p:spPr>
           <a:xfrm>
-            <a:off x="1097280" y="4937760"/>
-            <a:ext cx="7772400" cy="731520"/>
+            <a:off x="1097280" y="4389120"/>
+            <a:ext cx="9875520" cy="685800"/>
           </a:xfrm>
           <a:prstGeom prst="roundRect">
             <a:avLst/>
@@ -3288,15 +3288,85 @@
           <a:bodyPr rtlCol="0" anchor="ctr" wrap="square"/>
           <a:lstStyle/>
           <a:p>
-            <a:pPr algn="ctr">
-              <a:defRPr sz="1400" b="1">
+            <a:pPr algn="l"/>
+            <a:r>
+              <a:rPr sz="1300" b="1">
                 <a:solidFill>
                   <a:srgbClr val="FFFFFF"/>
                 </a:solidFill>
-              </a:defRPr>
-            </a:pPr>
-            <a:r>
-              <a:t>🌐 Live URL: https://bapanapallishankarportfolio.netlify.app/</a:t>
+              </a:rPr>
+              <a:t> 🌐  Live Website:  </a:t>
+            </a:r>
+            <a:r>
+              <a:rPr sz="1300" b="1" u="sng">
+                <a:solidFill>
+                  <a:srgbClr val="38BDF8"/>
+                </a:solidFill>
+                <a:hlinkClick r:id="rId2"/>
+              </a:rPr>
+              <a:t>https://bapanapallishankarportfolio.netlify.app/</a:t>
+            </a:r>
+          </a:p>
+        </p:txBody>
+      </p:sp>
+      <p:sp>
+        <p:nvSpPr>
+          <p:cNvPr id="6" name="Rounded Rectangle 5"/>
+          <p:cNvSpPr/>
+          <p:nvPr/>
+        </p:nvSpPr>
+        <p:spPr>
+          <a:xfrm>
+            <a:off x="1097280" y="5257800"/>
+            <a:ext cx="9875520" cy="685800"/>
+          </a:xfrm>
+          <a:prstGeom prst="roundRect">
+            <a:avLst/>
+          </a:prstGeom>
+          <a:solidFill>
+            <a:srgbClr val="1E293B"/>
+          </a:solidFill>
+          <a:ln>
+            <a:solidFill>
+              <a:srgbClr val="2563EB"/>
+            </a:solidFill>
+          </a:ln>
+        </p:spPr>
+        <p:style>
+          <a:lnRef idx="1">
+            <a:schemeClr val="accent1"/>
+          </a:lnRef>
+          <a:fillRef idx="3">
+            <a:schemeClr val="accent1"/>
+          </a:fillRef>
+          <a:effectRef idx="2">
+            <a:schemeClr val="accent1"/>
+          </a:effectRef>
+          <a:fontRef idx="minor">
+            <a:schemeClr val="lt1"/>
+          </a:fontRef>
+        </p:style>
+        <p:txBody>
+          <a:bodyPr rtlCol="0" anchor="ctr" wrap="square"/>
+          <a:lstStyle/>
+          <a:p>
+            <a:pPr algn="l"/>
+            <a:r>
+              <a:rPr sz="1300" b="1">
+                <a:solidFill>
+                  <a:srgbClr val="FFFFFF"/>
+                </a:solidFill>
+              </a:rPr>
+              <a:t> 🖥️  Full-Screen Web Presentation:  </a:t>
+            </a:r>
+            <a:r>
+              <a:rPr sz="1300" b="1" u="sng">
+                <a:solidFill>
+                  <a:srgbClr val="38BDF8"/>
+                </a:solidFill>
+                <a:hlinkClick r:id="rId3"/>
+              </a:rPr>
+              <a:t>https://bapanapallishankarportfolio.netlify.app/presentation.html</a:t>
             </a:r>
           </a:p>
         </p:txBody>
@@ -3429,7 +3499,7 @@
               </a:defRPr>
             </a:pPr>
             <a:r>
-              <a:t>Project Summary &amp; Live Deployment</a:t>
+              <a:t>Project Summary &amp; Clickable Live Links</a:t>
             </a:r>
           </a:p>
         </p:txBody>
@@ -3443,7 +3513,7 @@
         <p:spPr>
           <a:xfrm>
             <a:off x="731520" y="1645920"/>
-            <a:ext cx="5120640" cy="4389120"/>
+            <a:ext cx="5120640" cy="4572000"/>
           </a:xfrm>
           <a:prstGeom prst="roundRect">
             <a:avLst/>
@@ -3476,122 +3546,139 @@
           <a:lstStyle/>
           <a:p>
             <a:pPr algn="ctr">
-              <a:defRPr sz="1800" b="1">
+              <a:defRPr sz="1600" b="1">
                 <a:solidFill>
                   <a:srgbClr val="059669"/>
                 </a:solidFill>
               </a:defRPr>
             </a:pPr>
             <a:r>
-              <a:t>🌐 Live Deployments &amp; Repository</a:t>
+              <a:t>🌐 Direct Clickable Links</a:t>
             </a:r>
           </a:p>
           <a:p>
             <a:pPr>
               <a:spcBef>
-                <a:spcPts val="1000"/>
+                <a:spcPts val="800"/>
               </a:spcBef>
-              <a:defRPr sz="1300" b="1">
+            </a:pPr>
+            <a:r>
+              <a:rPr sz="1100" b="1">
                 <a:solidFill>
                   <a:srgbClr val="F8FAFC"/>
                 </a:solidFill>
-              </a:defRPr>
-            </a:pPr>
-            <a:r>
-              <a:t>• Netlify Live URL:</a:t>
-            </a:r>
-          </a:p>
-          <a:p>
-            <a:pPr>
-              <a:defRPr sz="1200">
-                <a:solidFill>
-                  <a:srgbClr val="2563EB"/>
-                </a:solidFill>
-              </a:defRPr>
-            </a:pPr>
-            <a:r>
-              <a:t>   https://bapanapallishankarportfolio.netlify.app/</a:t>
+              </a:rPr>
+              <a:t>• 🖥️ Full-Screen Web PPT:
+   </a:t>
+            </a:r>
+            <a:r>
+              <a:rPr sz="1000" b="1" u="sng">
+                <a:solidFill>
+                  <a:srgbClr val="38BDF8"/>
+                </a:solidFill>
+                <a:hlinkClick r:id="rId2"/>
+              </a:rPr>
+              <a:t>https://bapanapallishankarportfolio.netlify.app/presentation.html</a:t>
             </a:r>
           </a:p>
           <a:p>
             <a:pPr>
               <a:spcBef>
-                <a:spcPts val="1000"/>
+                <a:spcPts val="800"/>
               </a:spcBef>
-              <a:defRPr sz="1300" b="1">
+            </a:pPr>
+            <a:r>
+              <a:rPr sz="1100" b="1">
                 <a:solidFill>
                   <a:srgbClr val="F8FAFC"/>
                 </a:solidFill>
-              </a:defRPr>
-            </a:pPr>
-            <a:r>
-              <a:t>• GitHub Pages:</a:t>
-            </a:r>
-          </a:p>
-          <a:p>
-            <a:pPr>
-              <a:defRPr sz="1200">
-                <a:solidFill>
-                  <a:srgbClr val="2563EB"/>
-                </a:solidFill>
-              </a:defRPr>
-            </a:pPr>
-            <a:r>
-              <a:t>   https://shankarz9704.github.io/PORTFOLIO/</a:t>
+              </a:rPr>
+              <a:t>• 🚀 Netlify Live Website:
+   </a:t>
+            </a:r>
+            <a:r>
+              <a:rPr sz="1000" b="1" u="sng">
+                <a:solidFill>
+                  <a:srgbClr val="38BDF8"/>
+                </a:solidFill>
+                <a:hlinkClick r:id="rId3"/>
+              </a:rPr>
+              <a:t>https://bapanapallishankarportfolio.netlify.app/</a:t>
             </a:r>
           </a:p>
           <a:p>
             <a:pPr>
               <a:spcBef>
-                <a:spcPts val="1000"/>
+                <a:spcPts val="800"/>
               </a:spcBef>
-              <a:defRPr sz="1300" b="1">
+            </a:pPr>
+            <a:r>
+              <a:rPr sz="1100" b="1">
                 <a:solidFill>
                   <a:srgbClr val="F8FAFC"/>
                 </a:solidFill>
-              </a:defRPr>
-            </a:pPr>
-            <a:r>
-              <a:t>• GitHub Repository:</a:t>
-            </a:r>
-          </a:p>
-          <a:p>
-            <a:pPr>
-              <a:defRPr sz="1200">
-                <a:solidFill>
-                  <a:srgbClr val="2563EB"/>
-                </a:solidFill>
-              </a:defRPr>
-            </a:pPr>
-            <a:r>
-              <a:t>   https://github.com/Shankarz9704/PORTFOLIO</a:t>
+              </a:rPr>
+              <a:t>• 🌐 GitHub Pages Site:
+   </a:t>
+            </a:r>
+            <a:r>
+              <a:rPr sz="1000" b="1" u="sng">
+                <a:solidFill>
+                  <a:srgbClr val="38BDF8"/>
+                </a:solidFill>
+                <a:hlinkClick r:id="rId4"/>
+              </a:rPr>
+              <a:t>https://shankarz9704.github.io/PORTFOLIO/</a:t>
             </a:r>
           </a:p>
           <a:p>
             <a:pPr>
               <a:spcBef>
-                <a:spcPts val="1000"/>
+                <a:spcPts val="800"/>
               </a:spcBef>
-              <a:defRPr sz="1300" b="1">
+            </a:pPr>
+            <a:r>
+              <a:rPr sz="1100" b="1">
                 <a:solidFill>
                   <a:srgbClr val="F8FAFC"/>
                 </a:solidFill>
-              </a:defRPr>
-            </a:pPr>
-            <a:r>
-              <a:t>• Submission PDF:</a:t>
-            </a:r>
-          </a:p>
-          <a:p>
-            <a:pPr>
-              <a:defRPr sz="1200">
-                <a:solidFill>
-                  <a:srgbClr val="2563EB"/>
-                </a:solidFill>
-              </a:defRPr>
-            </a:pPr>
-            <a:r>
-              <a:t>   Portfolio_Website_Submission_Bapanapalli_Shankar.pdf</a:t>
+              </a:rPr>
+              <a:t>• 🐙 GitHub Repository:
+   </a:t>
+            </a:r>
+            <a:r>
+              <a:rPr sz="1000" b="1" u="sng">
+                <a:solidFill>
+                  <a:srgbClr val="38BDF8"/>
+                </a:solidFill>
+                <a:hlinkClick r:id="rId5"/>
+              </a:rPr>
+              <a:t>https://github.com/Shankarz9704/PORTFOLIO</a:t>
+            </a:r>
+          </a:p>
+          <a:p>
+            <a:pPr>
+              <a:spcBef>
+                <a:spcPts val="800"/>
+              </a:spcBef>
+            </a:pPr>
+            <a:r>
+              <a:rPr sz="1100" b="1">
+                <a:solidFill>
+                  <a:srgbClr val="F8FAFC"/>
+                </a:solidFill>
+              </a:rPr>
+              <a:t>• 📄 Submission PDF Document:
+   </a:t>
+            </a:r>
+            <a:r>
+              <a:rPr sz="1000" b="1" u="sng">
+                <a:solidFill>
+                  <a:srgbClr val="38BDF8"/>
+                </a:solidFill>
+                <a:hlinkClick r:id="rId6"/>
+              </a:rPr>
+              <a:t>https://github.com/Shankarz9704/PORTFOLIO/blob/main/Portfolio_Website_Submission_Bapanapalli_Shankar.pdf</a:t>
             </a:r>
           </a:p>
         </p:txBody>
@@ -3605,7 +3692,7 @@
         <p:spPr>
           <a:xfrm>
             <a:off x="6217920" y="1645920"/>
-            <a:ext cx="5212080" cy="4389120"/>
+            <a:ext cx="5212080" cy="4572000"/>
           </a:xfrm>
           <a:prstGeom prst="roundRect">
             <a:avLst/>
@@ -3638,7 +3725,7 @@
           <a:lstStyle/>
           <a:p>
             <a:pPr algn="ctr">
-              <a:defRPr sz="1800" b="1">
+              <a:defRPr sz="1600" b="1">
                 <a:solidFill>
                   <a:srgbClr val="059669"/>
                 </a:solidFill>
@@ -3651,9 +3738,9 @@
           <a:p>
             <a:pPr>
               <a:spcBef>
-                <a:spcPts val="1000"/>
+                <a:spcPts val="800"/>
               </a:spcBef>
-              <a:defRPr sz="1300">
+              <a:defRPr sz="1200">
                 <a:solidFill>
                   <a:srgbClr val="F8FAFC"/>
                 </a:solidFill>
@@ -3666,9 +3753,9 @@
           <a:p>
             <a:pPr>
               <a:spcBef>
-                <a:spcPts val="1000"/>
+                <a:spcPts val="800"/>
               </a:spcBef>
-              <a:defRPr sz="1300">
+              <a:defRPr sz="1200">
                 <a:solidFill>
                   <a:srgbClr val="F8FAFC"/>
                 </a:solidFill>
@@ -3681,9 +3768,9 @@
           <a:p>
             <a:pPr>
               <a:spcBef>
-                <a:spcPts val="1000"/>
+                <a:spcPts val="800"/>
               </a:spcBef>
-              <a:defRPr sz="1300">
+              <a:defRPr sz="1200">
                 <a:solidFill>
                   <a:srgbClr val="F8FAFC"/>
                 </a:solidFill>
@@ -3696,9 +3783,9 @@
           <a:p>
             <a:pPr>
               <a:spcBef>
-                <a:spcPts val="1000"/>
+                <a:spcPts val="800"/>
               </a:spcBef>
-              <a:defRPr sz="1300">
+              <a:defRPr sz="1200">
                 <a:solidFill>
                   <a:srgbClr val="F8FAFC"/>
                 </a:solidFill>
@@ -3711,9 +3798,9 @@
           <a:p>
             <a:pPr>
               <a:spcBef>
-                <a:spcPts val="1000"/>
+                <a:spcPts val="800"/>
               </a:spcBef>
-              <a:defRPr sz="1300">
+              <a:defRPr sz="1200">
                 <a:solidFill>
                   <a:srgbClr val="F8FAFC"/>
                 </a:solidFill>
@@ -3726,9 +3813,9 @@
           <a:p>
             <a:pPr>
               <a:spcBef>
-                <a:spcPts val="1000"/>
+                <a:spcPts val="800"/>
               </a:spcBef>
-              <a:defRPr sz="1300">
+              <a:defRPr sz="1200">
                 <a:solidFill>
                   <a:srgbClr val="F8FAFC"/>
                 </a:solidFill>
@@ -3882,7 +3969,7 @@
         <p:spPr>
           <a:xfrm>
             <a:off x="731520" y="1645920"/>
-            <a:ext cx="3328416" cy="4389120"/>
+            <a:ext cx="3328416" cy="4572000"/>
           </a:xfrm>
           <a:prstGeom prst="roundRect">
             <a:avLst/>
@@ -3926,9 +4013,9 @@
           <a:p>
             <a:pPr>
               <a:spcBef>
-                <a:spcPts val="1000"/>
+                <a:spcPts val="800"/>
               </a:spcBef>
-              <a:defRPr sz="1200">
+              <a:defRPr sz="1150">
                 <a:solidFill>
                   <a:srgbClr val="F8FAFC"/>
                 </a:solidFill>
@@ -3941,9 +4028,9 @@
           <a:p>
             <a:pPr>
               <a:spcBef>
-                <a:spcPts val="1000"/>
+                <a:spcPts val="800"/>
               </a:spcBef>
-              <a:defRPr sz="1200">
+              <a:defRPr sz="1150">
                 <a:solidFill>
                   <a:srgbClr val="F8FAFC"/>
                 </a:solidFill>
@@ -3956,9 +4043,9 @@
           <a:p>
             <a:pPr>
               <a:spcBef>
-                <a:spcPts val="1000"/>
+                <a:spcPts val="800"/>
               </a:spcBef>
-              <a:defRPr sz="1200">
+              <a:defRPr sz="1150">
                 <a:solidFill>
                   <a:srgbClr val="F8FAFC"/>
                 </a:solidFill>
@@ -3971,9 +4058,9 @@
           <a:p>
             <a:pPr>
               <a:spcBef>
-                <a:spcPts val="1000"/>
+                <a:spcPts val="800"/>
               </a:spcBef>
-              <a:defRPr sz="1200">
+              <a:defRPr sz="1150">
                 <a:solidFill>
                   <a:srgbClr val="F8FAFC"/>
                 </a:solidFill>
@@ -3994,7 +4081,7 @@
         <p:spPr>
           <a:xfrm>
             <a:off x="4425696" y="1645920"/>
-            <a:ext cx="3328416" cy="4389120"/>
+            <a:ext cx="3328416" cy="4572000"/>
           </a:xfrm>
           <a:prstGeom prst="roundRect">
             <a:avLst/>
@@ -4038,9 +4125,9 @@
           <a:p>
             <a:pPr>
               <a:spcBef>
-                <a:spcPts val="1000"/>
+                <a:spcPts val="800"/>
               </a:spcBef>
-              <a:defRPr sz="1200">
+              <a:defRPr sz="1150">
                 <a:solidFill>
                   <a:srgbClr val="F8FAFC"/>
                 </a:solidFill>
@@ -4053,9 +4140,9 @@
           <a:p>
             <a:pPr>
               <a:spcBef>
-                <a:spcPts val="1000"/>
+                <a:spcPts val="800"/>
               </a:spcBef>
-              <a:defRPr sz="1200">
+              <a:defRPr sz="1150">
                 <a:solidFill>
                   <a:srgbClr val="F8FAFC"/>
                 </a:solidFill>
@@ -4068,9 +4155,9 @@
           <a:p>
             <a:pPr>
               <a:spcBef>
-                <a:spcPts val="1000"/>
+                <a:spcPts val="800"/>
               </a:spcBef>
-              <a:defRPr sz="1200">
+              <a:defRPr sz="1150">
                 <a:solidFill>
                   <a:srgbClr val="F8FAFC"/>
                 </a:solidFill>
@@ -4083,9 +4170,9 @@
           <a:p>
             <a:pPr>
               <a:spcBef>
-                <a:spcPts val="1000"/>
+                <a:spcPts val="800"/>
               </a:spcBef>
-              <a:defRPr sz="1200">
+              <a:defRPr sz="1150">
                 <a:solidFill>
                   <a:srgbClr val="F8FAFC"/>
                 </a:solidFill>
@@ -4098,9 +4185,9 @@
           <a:p>
             <a:pPr>
               <a:spcBef>
-                <a:spcPts val="1000"/>
+                <a:spcPts val="800"/>
               </a:spcBef>
-              <a:defRPr sz="1200">
+              <a:defRPr sz="1150">
                 <a:solidFill>
                   <a:srgbClr val="F8FAFC"/>
                 </a:solidFill>
@@ -4121,7 +4208,7 @@
         <p:spPr>
           <a:xfrm>
             <a:off x="8119872" y="1645920"/>
-            <a:ext cx="3328416" cy="4389120"/>
+            <a:ext cx="3328416" cy="4572000"/>
           </a:xfrm>
           <a:prstGeom prst="roundRect">
             <a:avLst/>
@@ -4165,9 +4252,9 @@
           <a:p>
             <a:pPr>
               <a:spcBef>
-                <a:spcPts val="1000"/>
+                <a:spcPts val="800"/>
               </a:spcBef>
-              <a:defRPr sz="1200">
+              <a:defRPr sz="1150">
                 <a:solidFill>
                   <a:srgbClr val="F8FAFC"/>
                 </a:solidFill>
@@ -4180,24 +4267,24 @@
           <a:p>
             <a:pPr>
               <a:spcBef>
-                <a:spcPts val="1000"/>
+                <a:spcPts val="800"/>
               </a:spcBef>
-              <a:defRPr sz="1200">
+              <a:defRPr sz="1150">
                 <a:solidFill>
                   <a:srgbClr val="F8FAFC"/>
                 </a:solidFill>
               </a:defRPr>
             </a:pPr>
             <a:r>
-              <a:t>• Altruist Customer Management — Customer Support &amp; Process Associate</a:t>
+              <a:t>• Altruist Customer Management — Customer Support Associate</a:t>
             </a:r>
           </a:p>
           <a:p>
             <a:pPr>
               <a:spcBef>
-                <a:spcPts val="1000"/>
+                <a:spcPts val="800"/>
               </a:spcBef>
-              <a:defRPr sz="1200">
+              <a:defRPr sz="1150">
                 <a:solidFill>
                   <a:srgbClr val="F8FAFC"/>
                 </a:solidFill>
@@ -4210,9 +4297,9 @@
           <a:p>
             <a:pPr>
               <a:spcBef>
-                <a:spcPts val="1000"/>
+                <a:spcPts val="800"/>
               </a:spcBef>
-              <a:defRPr sz="1200">
+              <a:defRPr sz="1150">
                 <a:solidFill>
                   <a:srgbClr val="F8FAFC"/>
                 </a:solidFill>
@@ -4225,9 +4312,9 @@
           <a:p>
             <a:pPr>
               <a:spcBef>
-                <a:spcPts val="1000"/>
+                <a:spcPts val="800"/>
               </a:spcBef>
-              <a:defRPr sz="1200">
+              <a:defRPr sz="1150">
                 <a:solidFill>
                   <a:srgbClr val="F8FAFC"/>
                 </a:solidFill>
@@ -4381,7 +4468,7 @@
         <p:spPr>
           <a:xfrm>
             <a:off x="731520" y="1645920"/>
-            <a:ext cx="5120640" cy="2011680"/>
+            <a:ext cx="5120640" cy="2103120"/>
           </a:xfrm>
           <a:prstGeom prst="roundRect">
             <a:avLst/>
@@ -4414,7 +4501,7 @@
           <a:lstStyle/>
           <a:p>
             <a:pPr algn="ctr">
-              <a:defRPr sz="1600" b="1">
+              <a:defRPr sz="1500" b="1">
                 <a:solidFill>
                   <a:srgbClr val="059669"/>
                 </a:solidFill>
@@ -4427,9 +4514,9 @@
           <a:p>
             <a:pPr>
               <a:spcBef>
-                <a:spcPts val="600"/>
+                <a:spcPts val="400"/>
               </a:spcBef>
-              <a:defRPr sz="1200">
+              <a:defRPr sz="1150">
                 <a:solidFill>
                   <a:srgbClr val="F8FAFC"/>
                 </a:solidFill>
@@ -4450,7 +4537,7 @@
         <p:spPr>
           <a:xfrm>
             <a:off x="6217920" y="1645920"/>
-            <a:ext cx="5120640" cy="2011680"/>
+            <a:ext cx="5120640" cy="2103120"/>
           </a:xfrm>
           <a:prstGeom prst="roundRect">
             <a:avLst/>
@@ -4483,7 +4570,7 @@
           <a:lstStyle/>
           <a:p>
             <a:pPr algn="ctr">
-              <a:defRPr sz="1600" b="1">
+              <a:defRPr sz="1500" b="1">
                 <a:solidFill>
                   <a:srgbClr val="2563EB"/>
                 </a:solidFill>
@@ -4496,9 +4583,9 @@
           <a:p>
             <a:pPr>
               <a:spcBef>
-                <a:spcPts val="600"/>
+                <a:spcPts val="400"/>
               </a:spcBef>
-              <a:defRPr sz="1200">
+              <a:defRPr sz="1150">
                 <a:solidFill>
                   <a:srgbClr val="F8FAFC"/>
                 </a:solidFill>
@@ -4518,8 +4605,8 @@
         </p:nvSpPr>
         <p:spPr>
           <a:xfrm>
-            <a:off x="731520" y="3931920"/>
-            <a:ext cx="5120640" cy="2011680"/>
+            <a:off x="731520" y="4023360"/>
+            <a:ext cx="5120640" cy="2103120"/>
           </a:xfrm>
           <a:prstGeom prst="roundRect">
             <a:avLst/>
@@ -4552,7 +4639,7 @@
           <a:lstStyle/>
           <a:p>
             <a:pPr algn="ctr">
-              <a:defRPr sz="1600" b="1">
+              <a:defRPr sz="1500" b="1">
                 <a:solidFill>
                   <a:srgbClr val="059669"/>
                 </a:solidFill>
@@ -4565,9 +4652,9 @@
           <a:p>
             <a:pPr>
               <a:spcBef>
-                <a:spcPts val="600"/>
+                <a:spcPts val="400"/>
               </a:spcBef>
-              <a:defRPr sz="1200">
+              <a:defRPr sz="1150">
                 <a:solidFill>
                   <a:srgbClr val="F8FAFC"/>
                 </a:solidFill>
@@ -4587,8 +4674,8 @@
         </p:nvSpPr>
         <p:spPr>
           <a:xfrm>
-            <a:off x="6217920" y="3931920"/>
-            <a:ext cx="5120640" cy="2011680"/>
+            <a:off x="6217920" y="4023360"/>
+            <a:ext cx="5120640" cy="2103120"/>
           </a:xfrm>
           <a:prstGeom prst="roundRect">
             <a:avLst/>
@@ -4621,7 +4708,7 @@
           <a:lstStyle/>
           <a:p>
             <a:pPr algn="ctr">
-              <a:defRPr sz="1600" b="1">
+              <a:defRPr sz="1500" b="1">
                 <a:solidFill>
                   <a:srgbClr val="2563EB"/>
                 </a:solidFill>
@@ -4634,9 +4721,9 @@
           <a:p>
             <a:pPr>
               <a:spcBef>
-                <a:spcPts val="600"/>
+                <a:spcPts val="400"/>
               </a:spcBef>
-              <a:defRPr sz="1200">
+              <a:defRPr sz="1150">
                 <a:solidFill>
                   <a:srgbClr val="F8FAFC"/>
                 </a:solidFill>
@@ -4790,7 +4877,7 @@
         <p:spPr>
           <a:xfrm>
             <a:off x="731520" y="1645920"/>
-            <a:ext cx="3328416" cy="4389120"/>
+            <a:ext cx="3328416" cy="4572000"/>
           </a:xfrm>
           <a:prstGeom prst="roundRect">
             <a:avLst/>
@@ -4823,7 +4910,7 @@
           <a:lstStyle/>
           <a:p>
             <a:pPr algn="ctr">
-              <a:defRPr sz="1600" b="1">
+              <a:defRPr sz="1500" b="1">
                 <a:solidFill>
                   <a:srgbClr val="FFFFFF"/>
                 </a:solidFill>
@@ -4838,7 +4925,7 @@
               <a:spcBef>
                 <a:spcPts val="400"/>
               </a:spcBef>
-              <a:defRPr sz="1200" b="1">
+              <a:defRPr sz="1150" b="1">
                 <a:solidFill>
                   <a:srgbClr val="059669"/>
                 </a:solidFill>
@@ -4851,9 +4938,9 @@
           <a:p>
             <a:pPr>
               <a:spcBef>
-                <a:spcPts val="600"/>
+                <a:spcPts val="400"/>
               </a:spcBef>
-              <a:defRPr sz="1100">
+              <a:defRPr sz="1050">
                 <a:solidFill>
                   <a:srgbClr val="2563EB"/>
                 </a:solidFill>
@@ -4866,9 +4953,9 @@
           <a:p>
             <a:pPr>
               <a:spcBef>
-                <a:spcPts val="1200"/>
+                <a:spcPts val="800"/>
               </a:spcBef>
-              <a:defRPr sz="1200">
+              <a:defRPr sz="1150">
                 <a:solidFill>
                   <a:srgbClr val="F8FAFC"/>
                 </a:solidFill>
@@ -4876,6 +4963,30 @@
             </a:pPr>
             <a:r>
               <a:t>Built an enterprise-grade online mobile recharge system featuring user authentication, plan management, and instant payment transaction status processing.</a:t>
+            </a:r>
+          </a:p>
+          <a:p>
+            <a:pPr>
+              <a:spcBef>
+                <a:spcPts val="1000"/>
+              </a:spcBef>
+            </a:pPr>
+            <a:r>
+              <a:rPr sz="1050" b="1">
+                <a:solidFill>
+                  <a:srgbClr val="FFFFFF"/>
+                </a:solidFill>
+              </a:rPr>
+              <a:t>🔗 Link: </a:t>
+            </a:r>
+            <a:r>
+              <a:rPr sz="1050" b="1" u="sng">
+                <a:solidFill>
+                  <a:srgbClr val="38BDF8"/>
+                </a:solidFill>
+                <a:hlinkClick r:id="rId2"/>
+              </a:rPr>
+              <a:t>Access Project</a:t>
             </a:r>
           </a:p>
         </p:txBody>
@@ -4889,7 +5000,7 @@
         <p:spPr>
           <a:xfrm>
             <a:off x="4425696" y="1645920"/>
-            <a:ext cx="3328416" cy="4389120"/>
+            <a:ext cx="3328416" cy="4572000"/>
           </a:xfrm>
           <a:prstGeom prst="roundRect">
             <a:avLst/>
@@ -4922,7 +5033,7 @@
           <a:lstStyle/>
           <a:p>
             <a:pPr algn="ctr">
-              <a:defRPr sz="1600" b="1">
+              <a:defRPr sz="1500" b="1">
                 <a:solidFill>
                   <a:srgbClr val="FFFFFF"/>
                 </a:solidFill>
@@ -4937,7 +5048,7 @@
               <a:spcBef>
                 <a:spcPts val="400"/>
               </a:spcBef>
-              <a:defRPr sz="1200" b="1">
+              <a:defRPr sz="1150" b="1">
                 <a:solidFill>
                   <a:srgbClr val="059669"/>
                 </a:solidFill>
@@ -4950,9 +5061,9 @@
           <a:p>
             <a:pPr>
               <a:spcBef>
-                <a:spcPts val="600"/>
+                <a:spcPts val="400"/>
               </a:spcBef>
-              <a:defRPr sz="1100">
+              <a:defRPr sz="1050">
                 <a:solidFill>
                   <a:srgbClr val="2563EB"/>
                 </a:solidFill>
@@ -4965,9 +5076,9 @@
           <a:p>
             <a:pPr>
               <a:spcBef>
-                <a:spcPts val="1200"/>
+                <a:spcPts val="800"/>
               </a:spcBef>
-              <a:defRPr sz="1200">
+              <a:defRPr sz="1150">
                 <a:solidFill>
                   <a:srgbClr val="F8FAFC"/>
                 </a:solidFill>
@@ -4975,6 +5086,30 @@
             </a:pPr>
             <a:r>
               <a:t>Developed analytical pipelines and business intelligence dashboards to process structured datasets, perform statistical modeling, and generate actionable insights.</a:t>
+            </a:r>
+          </a:p>
+          <a:p>
+            <a:pPr>
+              <a:spcBef>
+                <a:spcPts val="1000"/>
+              </a:spcBef>
+            </a:pPr>
+            <a:r>
+              <a:rPr sz="1050" b="1">
+                <a:solidFill>
+                  <a:srgbClr val="FFFFFF"/>
+                </a:solidFill>
+              </a:rPr>
+              <a:t>🔗 Link: </a:t>
+            </a:r>
+            <a:r>
+              <a:rPr sz="1050" b="1" u="sng">
+                <a:solidFill>
+                  <a:srgbClr val="38BDF8"/>
+                </a:solidFill>
+                <a:hlinkClick r:id="rId2"/>
+              </a:rPr>
+              <a:t>Access Project</a:t>
             </a:r>
           </a:p>
         </p:txBody>
@@ -4988,7 +5123,7 @@
         <p:spPr>
           <a:xfrm>
             <a:off x="8119872" y="1645920"/>
-            <a:ext cx="3328416" cy="4389120"/>
+            <a:ext cx="3328416" cy="4572000"/>
           </a:xfrm>
           <a:prstGeom prst="roundRect">
             <a:avLst/>
@@ -5021,14 +5156,14 @@
           <a:lstStyle/>
           <a:p>
             <a:pPr algn="ctr">
-              <a:defRPr sz="1600" b="1">
+              <a:defRPr sz="1500" b="1">
                 <a:solidFill>
                   <a:srgbClr val="FFFFFF"/>
                 </a:solidFill>
               </a:defRPr>
             </a:pPr>
             <a:r>
-              <a:t>🌐 Portfolio Website (Shankar.dev)</a:t>
+              <a:t>🌐 Personal Portfolio Website</a:t>
             </a:r>
           </a:p>
           <a:p>
@@ -5036,7 +5171,7 @@
               <a:spcBef>
                 <a:spcPts val="400"/>
               </a:spcBef>
-              <a:defRPr sz="1200" b="1">
+              <a:defRPr sz="1150" b="1">
                 <a:solidFill>
                   <a:srgbClr val="059669"/>
                 </a:solidFill>
@@ -5049,9 +5184,9 @@
           <a:p>
             <a:pPr>
               <a:spcBef>
-                <a:spcPts val="600"/>
+                <a:spcPts val="400"/>
               </a:spcBef>
-              <a:defRPr sz="1100">
+              <a:defRPr sz="1050">
                 <a:solidFill>
                   <a:srgbClr val="2563EB"/>
                 </a:solidFill>
@@ -5064,9 +5199,9 @@
           <a:p>
             <a:pPr>
               <a:spcBef>
-                <a:spcPts val="1200"/>
+                <a:spcPts val="800"/>
               </a:spcBef>
-              <a:defRPr sz="1200">
+              <a:defRPr sz="1150">
                 <a:solidFill>
                   <a:srgbClr val="F8FAFC"/>
                 </a:solidFill>
@@ -5074,6 +5209,30 @@
             </a:pPr>
             <a:r>
               <a:t>Designed and deployed a modern interactive portfolio platform featuring theme switching, project filters, submission documentation, and live hosting.</a:t>
+            </a:r>
+          </a:p>
+          <a:p>
+            <a:pPr>
+              <a:spcBef>
+                <a:spcPts val="1000"/>
+              </a:spcBef>
+            </a:pPr>
+            <a:r>
+              <a:rPr sz="1050" b="1">
+                <a:solidFill>
+                  <a:srgbClr val="FFFFFF"/>
+                </a:solidFill>
+              </a:rPr>
+              <a:t>🔗 Link: </a:t>
+            </a:r>
+            <a:r>
+              <a:rPr sz="1050" b="1" u="sng">
+                <a:solidFill>
+                  <a:srgbClr val="38BDF8"/>
+                </a:solidFill>
+                <a:hlinkClick r:id="rId3"/>
+              </a:rPr>
+              <a:t>Access Project</a:t>
             </a:r>
           </a:p>
         </p:txBody>
@@ -5170,7 +5329,7 @@
               </a:defRPr>
             </a:pPr>
             <a:r>
-              <a:t>CONTACT &amp; VERIFICATION</a:t>
+              <a:t>CONTACT &amp; EASY ACCESS LINKS</a:t>
             </a:r>
           </a:p>
         </p:txBody>
@@ -5206,7 +5365,7 @@
               </a:defRPr>
             </a:pPr>
             <a:r>
-              <a:t>Developer Contact Details</a:t>
+              <a:t>Developer Contact &amp; Complete Link Directory</a:t>
             </a:r>
           </a:p>
         </p:txBody>
@@ -5219,8 +5378,8 @@
         </p:nvSpPr>
         <p:spPr>
           <a:xfrm>
-            <a:off x="2011680" y="1645920"/>
-            <a:ext cx="8168335" cy="4389120"/>
+            <a:off x="1371600" y="1645920"/>
+            <a:ext cx="9445752" cy="4572000"/>
           </a:xfrm>
           <a:prstGeom prst="roundRect">
             <a:avLst/>
@@ -5253,7 +5412,7 @@
           <a:lstStyle/>
           <a:p>
             <a:pPr algn="ctr">
-              <a:defRPr sz="2400" b="1">
+              <a:defRPr sz="2200" b="1">
                 <a:solidFill>
                   <a:srgbClr val="FFFFFF"/>
                 </a:solidFill>
@@ -5266,91 +5425,159 @@
           <a:p>
             <a:pPr>
               <a:spcBef>
-                <a:spcPts val="400"/>
-              </a:spcBef>
-              <a:defRPr sz="1500">
-                <a:solidFill>
-                  <a:srgbClr val="059669"/>
-                </a:solidFill>
-              </a:defRPr>
-            </a:pPr>
-            <a:r>
-              <a:t>Python &amp; Java Full Stack Developer | AI Data Analyst</a:t>
-            </a:r>
-          </a:p>
-          <a:p>
-            <a:pPr>
-              <a:spcBef>
-                <a:spcPts val="1200"/>
+                <a:spcPts val="200"/>
               </a:spcBef>
               <a:defRPr sz="1400">
                 <a:solidFill>
+                  <a:srgbClr val="059669"/>
+                </a:solidFill>
+              </a:defRPr>
+            </a:pPr>
+            <a:r>
+              <a:t>Python &amp; Java Full Stack Developer | AI Data Analyst</a:t>
+            </a:r>
+          </a:p>
+          <a:p>
+            <a:pPr>
+              <a:spcBef>
+                <a:spcPts val="800"/>
+              </a:spcBef>
+            </a:pPr>
+            <a:r>
+              <a:rPr sz="1200" b="1">
+                <a:solidFill>
                   <a:srgbClr val="F8FAFC"/>
                 </a:solidFill>
-              </a:defRPr>
-            </a:pPr>
-            <a:r>
-              <a:t>📧 Email:  shankarcode291439@gmail.com</a:t>
+              </a:rPr>
+              <a:t>🖥️ Full-Screen Web Presentation:  </a:t>
+            </a:r>
+            <a:r>
+              <a:rPr sz="1200" b="1" u="sng">
+                <a:solidFill>
+                  <a:srgbClr val="38BDF8"/>
+                </a:solidFill>
+                <a:hlinkClick r:id="rId2"/>
+              </a:rPr>
+              <a:t>https://bapanapallishankarportfolio.netlify.app/presentation.html</a:t>
             </a:r>
           </a:p>
           <a:p>
             <a:pPr>
               <a:spcBef>
-                <a:spcPts val="1200"/>
+                <a:spcPts val="800"/>
               </a:spcBef>
-              <a:defRPr sz="1400">
+            </a:pPr>
+            <a:r>
+              <a:rPr sz="1200" b="1">
                 <a:solidFill>
                   <a:srgbClr val="F8FAFC"/>
                 </a:solidFill>
-              </a:defRPr>
-            </a:pPr>
-            <a:r>
-              <a:t>📞 Phone:  +91 7842161185</a:t>
+              </a:rPr>
+              <a:t>🌐 Live Portfolio Website:  </a:t>
+            </a:r>
+            <a:r>
+              <a:rPr sz="1200" b="1" u="sng">
+                <a:solidFill>
+                  <a:srgbClr val="38BDF8"/>
+                </a:solidFill>
+                <a:hlinkClick r:id="rId3"/>
+              </a:rPr>
+              <a:t>https://bapanapallishankarportfolio.netlify.app/</a:t>
             </a:r>
           </a:p>
           <a:p>
             <a:pPr>
               <a:spcBef>
-                <a:spcPts val="1200"/>
+                <a:spcPts val="800"/>
               </a:spcBef>
-              <a:defRPr sz="1400">
+            </a:pPr>
+            <a:r>
+              <a:rPr sz="1200" b="1">
                 <a:solidFill>
                   <a:srgbClr val="F8FAFC"/>
                 </a:solidFill>
-              </a:defRPr>
-            </a:pPr>
-            <a:r>
-              <a:t>🌐 Live Portfolio:  https://bapanapallishankarportfolio.netlify.app/</a:t>
+              </a:rPr>
+              <a:t>🐙 GitHub Repository:  </a:t>
+            </a:r>
+            <a:r>
+              <a:rPr sz="1200" b="1" u="sng">
+                <a:solidFill>
+                  <a:srgbClr val="38BDF8"/>
+                </a:solidFill>
+                <a:hlinkClick r:id="rId4"/>
+              </a:rPr>
+              <a:t>https://github.com/Shankarz9704/PORTFOLIO</a:t>
             </a:r>
           </a:p>
           <a:p>
             <a:pPr>
               <a:spcBef>
-                <a:spcPts val="1200"/>
+                <a:spcPts val="800"/>
               </a:spcBef>
-              <a:defRPr sz="1400">
+            </a:pPr>
+            <a:r>
+              <a:rPr sz="1200" b="1">
                 <a:solidFill>
                   <a:srgbClr val="F8FAFC"/>
                 </a:solidFill>
-              </a:defRPr>
-            </a:pPr>
-            <a:r>
-              <a:t>🐙 GitHub:  https://github.com/Shankarz9704</a:t>
+              </a:rPr>
+              <a:t>💼 LinkedIn Profile:  </a:t>
+            </a:r>
+            <a:r>
+              <a:rPr sz="1200" b="1" u="sng">
+                <a:solidFill>
+                  <a:srgbClr val="38BDF8"/>
+                </a:solidFill>
+                <a:hlinkClick r:id="rId5"/>
+              </a:rPr>
+              <a:t>https://www.linkedin.com/in/shankar9704</a:t>
             </a:r>
           </a:p>
           <a:p>
             <a:pPr>
               <a:spcBef>
-                <a:spcPts val="1200"/>
+                <a:spcPts val="800"/>
               </a:spcBef>
-              <a:defRPr sz="1400">
+            </a:pPr>
+            <a:r>
+              <a:rPr sz="1200" b="1">
                 <a:solidFill>
                   <a:srgbClr val="F8FAFC"/>
                 </a:solidFill>
-              </a:defRPr>
-            </a:pPr>
-            <a:r>
-              <a:t>💼 LinkedIn:  https://www.linkedin.com/in/shankar9704</a:t>
+              </a:rPr>
+              <a:t>📧 Email Contact:  </a:t>
+            </a:r>
+            <a:r>
+              <a:rPr sz="1200" b="1" u="sng">
+                <a:solidFill>
+                  <a:srgbClr val="38BDF8"/>
+                </a:solidFill>
+                <a:hlinkClick r:id="rId6"/>
+              </a:rPr>
+              <a:t>mailto:shankarcode291439@gmail.com</a:t>
+            </a:r>
+          </a:p>
+          <a:p>
+            <a:pPr>
+              <a:spcBef>
+                <a:spcPts val="800"/>
+              </a:spcBef>
+            </a:pPr>
+            <a:r>
+              <a:rPr sz="1200" b="1">
+                <a:solidFill>
+                  <a:srgbClr val="F8FAFC"/>
+                </a:solidFill>
+              </a:rPr>
+              <a:t>📞 Phone:  </a:t>
+            </a:r>
+            <a:r>
+              <a:rPr sz="1200">
+                <a:solidFill>
+                  <a:srgbClr val="38BDF8"/>
+                </a:solidFill>
+              </a:rPr>
+              <a:t>+91 7842161185</a:t>
             </a:r>
           </a:p>
         </p:txBody>

</xml_diff>